<commit_message>
feat: build bms project pulse app
</commit_message>
<xml_diff>
--- a/BMS_AI_Presentation.pptx
+++ b/BMS_AI_Presentation.pptx
@@ -3118,7 +3118,7 @@
             <a:avLst/>
           </a:prstGeom>
           <a:solidFill>
-            <a:srgbClr val="007A3D"/>
+            <a:srgbClr val="1B2A4A"/>
           </a:solidFill>
           <a:ln>
             <a:noFill/>
@@ -3284,7 +3284,7 @@
       </p:sp>
       <p:pic>
         <p:nvPicPr>
-          <p:cNvPr id="8" name="Picture 7" descr="durham-logo-official.png"/>
+          <p:cNvPr id="8" name="Picture 7" descr="image.png"/>
           <p:cNvPicPr>
             <a:picLocks noChangeAspect="1"/>
           </p:cNvPicPr>
@@ -3298,31 +3298,7 @@
         </p:blipFill>
         <p:spPr>
           <a:xfrm>
-            <a:off x="10314432" y="6127255"/>
-            <a:ext cx="1645920" cy="502145"/>
-          </a:xfrm>
-          <a:prstGeom prst="rect">
-            <a:avLst/>
-          </a:prstGeom>
-        </p:spPr>
-      </p:pic>
-      <p:pic>
-        <p:nvPicPr>
-          <p:cNvPr id="9" name="Picture 8" descr="image.png"/>
-          <p:cNvPicPr>
-            <a:picLocks noChangeAspect="1"/>
-          </p:cNvPicPr>
-          <p:nvPr/>
-        </p:nvPicPr>
-        <p:blipFill>
-          <a:blip r:embed="rId4"/>
-          <a:stretch>
-            <a:fillRect/>
-          </a:stretch>
-        </p:blipFill>
-        <p:spPr>
-          <a:xfrm>
-            <a:off x="10314432" y="6127255"/>
+            <a:off x="10360152" y="6286887"/>
             <a:ext cx="1645920" cy="502145"/>
           </a:xfrm>
           <a:prstGeom prst="rect">
@@ -3562,7 +3538,7 @@
         </p:blipFill>
         <p:spPr>
           <a:xfrm>
-            <a:off x="10314432" y="6127255"/>
+            <a:off x="10360152" y="6286887"/>
             <a:ext cx="1645920" cy="502145"/>
           </a:xfrm>
           <a:prstGeom prst="rect">
@@ -3611,7 +3587,7 @@
             <a:avLst/>
           </a:prstGeom>
           <a:solidFill>
-            <a:srgbClr val="007A3D"/>
+            <a:srgbClr val="1B2A4A"/>
           </a:solidFill>
           <a:ln>
             <a:noFill/>
@@ -4192,7 +4168,7 @@
             <a:avLst/>
           </a:prstGeom>
           <a:solidFill>
-            <a:srgbClr val="003F87"/>
+            <a:srgbClr val="1B2A4A"/>
           </a:solidFill>
           <a:ln>
             <a:noFill/>
@@ -4235,7 +4211,7 @@
             <a:avLst/>
           </a:prstGeom>
           <a:solidFill>
-            <a:srgbClr val="F5A800"/>
+            <a:srgbClr val="1B2A4A"/>
           </a:solidFill>
           <a:ln>
             <a:noFill/>
@@ -4279,7 +4255,7 @@
         </p:blipFill>
         <p:spPr>
           <a:xfrm>
-            <a:off x="10314432" y="6127255"/>
+            <a:off x="10360152" y="6286887"/>
             <a:ext cx="1645920" cy="502145"/>
           </a:xfrm>
           <a:prstGeom prst="rect">
@@ -4584,7 +4560,7 @@
             <a:avLst/>
           </a:prstGeom>
           <a:solidFill>
-            <a:srgbClr val="007A3D"/>
+            <a:srgbClr val="1B2A4A"/>
           </a:solidFill>
           <a:ln>
             <a:noFill/>
@@ -4627,7 +4603,7 @@
             <a:avLst/>
           </a:prstGeom>
           <a:solidFill>
-            <a:srgbClr val="003F87"/>
+            <a:srgbClr val="1B2A4A"/>
           </a:solidFill>
           <a:ln>
             <a:noFill/>
@@ -4670,7 +4646,7 @@
             <a:avLst/>
           </a:prstGeom>
           <a:solidFill>
-            <a:srgbClr val="F5A800"/>
+            <a:srgbClr val="1B2A4A"/>
           </a:solidFill>
           <a:ln>
             <a:noFill/>
@@ -4714,7 +4690,7 @@
         </p:blipFill>
         <p:spPr>
           <a:xfrm>
-            <a:off x="10314432" y="6127255"/>
+            <a:off x="10360152" y="6286887"/>
             <a:ext cx="1645920" cy="502145"/>
           </a:xfrm>
           <a:prstGeom prst="rect">
@@ -5225,7 +5201,7 @@
             <a:avLst/>
           </a:prstGeom>
           <a:solidFill>
-            <a:srgbClr val="007A3D"/>
+            <a:srgbClr val="1B2A4A"/>
           </a:solidFill>
           <a:ln>
             <a:noFill/>
@@ -5268,7 +5244,7 @@
             <a:avLst/>
           </a:prstGeom>
           <a:solidFill>
-            <a:srgbClr val="003F87"/>
+            <a:srgbClr val="1B2A4A"/>
           </a:solidFill>
           <a:ln>
             <a:noFill/>
@@ -5311,7 +5287,7 @@
             <a:avLst/>
           </a:prstGeom>
           <a:solidFill>
-            <a:srgbClr val="F5A800"/>
+            <a:srgbClr val="1B2A4A"/>
           </a:solidFill>
           <a:ln>
             <a:noFill/>
@@ -5355,7 +5331,7 @@
         </p:blipFill>
         <p:spPr>
           <a:xfrm>
-            <a:off x="10314432" y="6127255"/>
+            <a:off x="10360152" y="6286887"/>
             <a:ext cx="1645920" cy="502145"/>
           </a:xfrm>
           <a:prstGeom prst="rect">
@@ -5925,7 +5901,7 @@
             <a:avLst/>
           </a:prstGeom>
           <a:solidFill>
-            <a:srgbClr val="007A3D"/>
+            <a:srgbClr val="1B2A4A"/>
           </a:solidFill>
           <a:ln>
             <a:noFill/>
@@ -5968,7 +5944,7 @@
             <a:avLst/>
           </a:prstGeom>
           <a:solidFill>
-            <a:srgbClr val="003F87"/>
+            <a:srgbClr val="1B2A4A"/>
           </a:solidFill>
           <a:ln>
             <a:noFill/>
@@ -6011,7 +5987,7 @@
             <a:avLst/>
           </a:prstGeom>
           <a:solidFill>
-            <a:srgbClr val="F5A800"/>
+            <a:srgbClr val="1B2A4A"/>
           </a:solidFill>
           <a:ln>
             <a:noFill/>
@@ -6055,7 +6031,7 @@
         </p:blipFill>
         <p:spPr>
           <a:xfrm>
-            <a:off x="10314432" y="6127255"/>
+            <a:off x="10360152" y="6286887"/>
             <a:ext cx="1645920" cy="502145"/>
           </a:xfrm>
           <a:prstGeom prst="rect">
@@ -6104,7 +6080,7 @@
             <a:avLst/>
           </a:prstGeom>
           <a:solidFill>
-            <a:srgbClr val="007A3D"/>
+            <a:srgbClr val="1B2A4A"/>
           </a:solidFill>
           <a:ln>
             <a:noFill/>
@@ -6642,7 +6618,7 @@
             <a:avLst/>
           </a:prstGeom>
           <a:solidFill>
-            <a:srgbClr val="003F87"/>
+            <a:srgbClr val="1B2A4A"/>
           </a:solidFill>
           <a:ln>
             <a:noFill/>
@@ -6685,7 +6661,7 @@
             <a:avLst/>
           </a:prstGeom>
           <a:solidFill>
-            <a:srgbClr val="F5A800"/>
+            <a:srgbClr val="1B2A4A"/>
           </a:solidFill>
           <a:ln>
             <a:noFill/>
@@ -6729,7 +6705,7 @@
         </p:blipFill>
         <p:spPr>
           <a:xfrm>
-            <a:off x="10314432" y="6127255"/>
+            <a:off x="10360152" y="6286887"/>
             <a:ext cx="1645920" cy="502145"/>
           </a:xfrm>
           <a:prstGeom prst="rect">
@@ -7334,7 +7310,7 @@
             <a:avLst/>
           </a:prstGeom>
           <a:solidFill>
-            <a:srgbClr val="007A3D"/>
+            <a:srgbClr val="1B2A4A"/>
           </a:solidFill>
           <a:ln>
             <a:noFill/>
@@ -7377,7 +7353,7 @@
             <a:avLst/>
           </a:prstGeom>
           <a:solidFill>
-            <a:srgbClr val="003F87"/>
+            <a:srgbClr val="1B2A4A"/>
           </a:solidFill>
           <a:ln>
             <a:noFill/>
@@ -7420,7 +7396,7 @@
             <a:avLst/>
           </a:prstGeom>
           <a:solidFill>
-            <a:srgbClr val="F5A800"/>
+            <a:srgbClr val="1B2A4A"/>
           </a:solidFill>
           <a:ln>
             <a:noFill/>
@@ -7464,7 +7440,7 @@
         </p:blipFill>
         <p:spPr>
           <a:xfrm>
-            <a:off x="10314432" y="6127255"/>
+            <a:off x="10360152" y="6286887"/>
             <a:ext cx="1645920" cy="502145"/>
           </a:xfrm>
           <a:prstGeom prst="rect">

</xml_diff>